<commit_message>
Add PDF and update PPTX for fake_news_detector
Add a generated PDF export of the fake_news_detector presentation and replace the existing PowerPoint (.pptx) with an updated binary version. This commit adds fake_news_detector.pdf and updates fake_news_detector.pptx to include the latest slide changes.
</commit_message>
<xml_diff>
--- a/fake_news_detector.pptx
+++ b/fake_news_detector.pptx
@@ -5,7 +5,7 @@
     <p:sldMasterId id="2147483659" r:id="rId1"/>
   </p:sldMasterIdLst>
   <p:notesMasterIdLst>
-    <p:notesMasterId r:id="rId30"/>
+    <p:notesMasterId r:id="rId31"/>
   </p:notesMasterIdLst>
   <p:sldIdLst>
     <p:sldId id="256" r:id="rId2"/>
@@ -28,31 +28,32 @@
     <p:sldId id="278" r:id="rId19"/>
     <p:sldId id="279" r:id="rId20"/>
     <p:sldId id="261" r:id="rId21"/>
-    <p:sldId id="280" r:id="rId22"/>
-    <p:sldId id="281" r:id="rId23"/>
+    <p:sldId id="281" r:id="rId22"/>
+    <p:sldId id="280" r:id="rId23"/>
     <p:sldId id="262" r:id="rId24"/>
     <p:sldId id="282" r:id="rId25"/>
-    <p:sldId id="263" r:id="rId26"/>
-    <p:sldId id="283" r:id="rId27"/>
-    <p:sldId id="264" r:id="rId28"/>
-    <p:sldId id="265" r:id="rId29"/>
+    <p:sldId id="284" r:id="rId26"/>
+    <p:sldId id="263" r:id="rId27"/>
+    <p:sldId id="283" r:id="rId28"/>
+    <p:sldId id="264" r:id="rId29"/>
+    <p:sldId id="265" r:id="rId30"/>
   </p:sldIdLst>
   <p:sldSz cx="9144000" cy="5143500" type="screen16x9"/>
   <p:notesSz cx="6858000" cy="9144000"/>
   <p:embeddedFontLst>
     <p:embeddedFont>
       <p:font typeface="Open Sans" panose="020B0606030504020204" pitchFamily="34" charset="0"/>
-      <p:regular r:id="rId31"/>
-      <p:bold r:id="rId32"/>
-      <p:italic r:id="rId33"/>
-      <p:boldItalic r:id="rId34"/>
+      <p:regular r:id="rId32"/>
+      <p:bold r:id="rId33"/>
+      <p:italic r:id="rId34"/>
+      <p:boldItalic r:id="rId35"/>
     </p:embeddedFont>
     <p:embeddedFont>
       <p:font typeface="Roboto Serif" panose="020B0604020202020204" charset="0"/>
-      <p:regular r:id="rId35"/>
-      <p:bold r:id="rId36"/>
-      <p:italic r:id="rId37"/>
-      <p:boldItalic r:id="rId38"/>
+      <p:regular r:id="rId36"/>
+      <p:bold r:id="rId37"/>
+      <p:italic r:id="rId38"/>
+      <p:boldItalic r:id="rId39"/>
     </p:embeddedFont>
   </p:embeddedFontLst>
   <p:defaultTextStyle>
@@ -301,6 +302,14 @@
     </p:ext>
   </p:extLst>
 </p:presentation>
+</file>
+
+<file path=ppt/revisionInfo.xml><?xml version="1.0" encoding="utf-8"?>
+<p1510:revInfo xmlns:a="http://schemas.openxmlformats.org/drawingml/2006/main" xmlns:r="http://schemas.openxmlformats.org/officeDocument/2006/relationships" xmlns:p1510="http://schemas.microsoft.com/office/powerpoint/2015/10/main">
+  <p1510:revLst>
+    <p1510:client id="{695D9EFB-6750-BCD3-F434-FC7B2CA838F7}" v="100" dt="2026-05-09T10:37:09.935"/>
+  </p1510:revLst>
+</p1510:revInfo>
 </file>
 
 <file path=ppt/notesMasters/notesMaster1.xml><?xml version="1.0" encoding="utf-8"?>
@@ -2250,7 +2259,7 @@
     </p:spTree>
     <p:extLst>
       <p:ext uri="{BB962C8B-B14F-4D97-AF65-F5344CB8AC3E}">
-        <p14:creationId xmlns:p14="http://schemas.microsoft.com/office/powerpoint/2010/main" val="985462890"/>
+        <p14:creationId xmlns:p14="http://schemas.microsoft.com/office/powerpoint/2010/main" val="2440978451"/>
       </p:ext>
     </p:extLst>
   </p:cSld>
@@ -2359,7 +2368,7 @@
     </p:spTree>
     <p:extLst>
       <p:ext uri="{BB962C8B-B14F-4D97-AF65-F5344CB8AC3E}">
-        <p14:creationId xmlns:p14="http://schemas.microsoft.com/office/powerpoint/2010/main" val="2440978451"/>
+        <p14:creationId xmlns:p14="http://schemas.microsoft.com/office/powerpoint/2010/main" val="985462890"/>
       </p:ext>
     </p:extLst>
   </p:cSld>
@@ -2592,7 +2601,13 @@
   <p:cSld>
     <p:spTree>
       <p:nvGrpSpPr>
-        <p:cNvPr id="1" name="Shape 62"/>
+        <p:cNvPr id="1" name="Shape 62">
+          <a:extLst>
+            <a:ext uri="{FF2B5EF4-FFF2-40B4-BE49-F238E27FC236}">
+              <a16:creationId xmlns:a16="http://schemas.microsoft.com/office/drawing/2014/main" id="{54153BDD-27F0-905C-98F0-70D652F4D178}"/>
+            </a:ext>
+          </a:extLst>
+        </p:cNvPr>
         <p:cNvGrpSpPr/>
         <p:nvPr/>
       </p:nvGrpSpPr>
@@ -2606,7 +2621,13 @@
       </p:grpSpPr>
       <p:sp>
         <p:nvSpPr>
-          <p:cNvPr id="63" name="Google Shape;63;g3421488a45a_0_775:notes"/>
+          <p:cNvPr id="63" name="Google Shape;63;g3421488a45a_0_775:notes">
+            <a:extLst>
+              <a:ext uri="{FF2B5EF4-FFF2-40B4-BE49-F238E27FC236}">
+                <a16:creationId xmlns:a16="http://schemas.microsoft.com/office/drawing/2014/main" id="{B63D2A43-2D60-2EA0-FC16-9A01BBCA8552}"/>
+              </a:ext>
+            </a:extLst>
+          </p:cNvPr>
           <p:cNvSpPr>
             <a:spLocks noGrp="1" noRot="1" noChangeAspect="1"/>
           </p:cNvSpPr>
@@ -2647,7 +2668,13 @@
       </p:sp>
       <p:sp>
         <p:nvSpPr>
-          <p:cNvPr id="64" name="Google Shape;64;g3421488a45a_0_775:notes"/>
+          <p:cNvPr id="64" name="Google Shape;64;g3421488a45a_0_775:notes">
+            <a:extLst>
+              <a:ext uri="{FF2B5EF4-FFF2-40B4-BE49-F238E27FC236}">
+                <a16:creationId xmlns:a16="http://schemas.microsoft.com/office/drawing/2014/main" id="{4E8FCADC-5F82-6A41-7106-006A9D8F5CA0}"/>
+              </a:ext>
+            </a:extLst>
+          </p:cNvPr>
           <p:cNvSpPr txBox="1">
             <a:spLocks noGrp="1"/>
           </p:cNvSpPr>
@@ -2686,7 +2713,7 @@
     </p:spTree>
     <p:extLst>
       <p:ext uri="{BB962C8B-B14F-4D97-AF65-F5344CB8AC3E}">
-        <p14:creationId xmlns:p14="http://schemas.microsoft.com/office/powerpoint/2010/main" val="2721705800"/>
+        <p14:creationId xmlns:p14="http://schemas.microsoft.com/office/powerpoint/2010/main" val="578864004"/>
       </p:ext>
     </p:extLst>
   </p:cSld>
@@ -2795,7 +2822,7 @@
     </p:spTree>
     <p:extLst>
       <p:ext uri="{BB962C8B-B14F-4D97-AF65-F5344CB8AC3E}">
-        <p14:creationId xmlns:p14="http://schemas.microsoft.com/office/powerpoint/2010/main" val="1847085589"/>
+        <p14:creationId xmlns:p14="http://schemas.microsoft.com/office/powerpoint/2010/main" val="2721705800"/>
       </p:ext>
     </p:extLst>
   </p:cSld>
@@ -2904,6 +2931,115 @@
     </p:spTree>
     <p:extLst>
       <p:ext uri="{BB962C8B-B14F-4D97-AF65-F5344CB8AC3E}">
+        <p14:creationId xmlns:p14="http://schemas.microsoft.com/office/powerpoint/2010/main" val="1847085589"/>
+      </p:ext>
+    </p:extLst>
+  </p:cSld>
+  <p:clrMapOvr>
+    <a:masterClrMapping/>
+  </p:clrMapOvr>
+</p:notes>
+</file>
+
+<file path=ppt/notesSlides/notesSlide28.xml><?xml version="1.0" encoding="utf-8"?>
+<p:notes xmlns:a="http://schemas.openxmlformats.org/drawingml/2006/main" xmlns:r="http://schemas.openxmlformats.org/officeDocument/2006/relationships" xmlns:p="http://schemas.openxmlformats.org/presentationml/2006/main" showMasterSp="0" showMasterPhAnim="0">
+  <p:cSld>
+    <p:spTree>
+      <p:nvGrpSpPr>
+        <p:cNvPr id="1" name="Shape 62"/>
+        <p:cNvGrpSpPr/>
+        <p:nvPr/>
+      </p:nvGrpSpPr>
+      <p:grpSpPr>
+        <a:xfrm>
+          <a:off x="0" y="0"/>
+          <a:ext cx="0" cy="0"/>
+          <a:chOff x="0" y="0"/>
+          <a:chExt cx="0" cy="0"/>
+        </a:xfrm>
+      </p:grpSpPr>
+      <p:sp>
+        <p:nvSpPr>
+          <p:cNvPr id="63" name="Google Shape;63;g3421488a45a_0_775:notes"/>
+          <p:cNvSpPr>
+            <a:spLocks noGrp="1" noRot="1" noChangeAspect="1"/>
+          </p:cNvSpPr>
+          <p:nvPr>
+            <p:ph type="sldImg" idx="2"/>
+          </p:nvPr>
+        </p:nvSpPr>
+        <p:spPr>
+          <a:xfrm>
+            <a:off x="381000" y="685800"/>
+            <a:ext cx="6096000" cy="3429000"/>
+          </a:xfrm>
+          <a:custGeom>
+            <a:avLst/>
+            <a:gdLst/>
+            <a:ahLst/>
+            <a:cxnLst/>
+            <a:rect l="l" t="t" r="r" b="b"/>
+            <a:pathLst>
+              <a:path w="120000" h="120000" extrusionOk="0">
+                <a:moveTo>
+                  <a:pt x="0" y="0"/>
+                </a:moveTo>
+                <a:lnTo>
+                  <a:pt x="120000" y="0"/>
+                </a:lnTo>
+                <a:lnTo>
+                  <a:pt x="120000" y="120000"/>
+                </a:lnTo>
+                <a:lnTo>
+                  <a:pt x="0" y="120000"/>
+                </a:lnTo>
+                <a:close/>
+              </a:path>
+            </a:pathLst>
+          </a:custGeom>
+        </p:spPr>
+      </p:sp>
+      <p:sp>
+        <p:nvSpPr>
+          <p:cNvPr id="64" name="Google Shape;64;g3421488a45a_0_775:notes"/>
+          <p:cNvSpPr txBox="1">
+            <a:spLocks noGrp="1"/>
+          </p:cNvSpPr>
+          <p:nvPr>
+            <p:ph type="body" idx="1"/>
+          </p:nvPr>
+        </p:nvSpPr>
+        <p:spPr>
+          <a:xfrm>
+            <a:off x="685800" y="4343400"/>
+            <a:ext cx="5486400" cy="4114800"/>
+          </a:xfrm>
+          <a:prstGeom prst="rect">
+            <a:avLst/>
+          </a:prstGeom>
+        </p:spPr>
+        <p:txBody>
+          <a:bodyPr spcFirstLastPara="1" wrap="square" lIns="91425" tIns="91425" rIns="91425" bIns="91425" anchor="t" anchorCtr="0">
+            <a:noAutofit/>
+          </a:bodyPr>
+          <a:lstStyle/>
+          <a:p>
+            <a:pPr marL="0" lvl="0" indent="0" algn="l" rtl="0">
+              <a:spcBef>
+                <a:spcPts val="0"/>
+              </a:spcBef>
+              <a:spcAft>
+                <a:spcPts val="0"/>
+              </a:spcAft>
+              <a:buNone/>
+            </a:pPr>
+            <a:endParaRPr/>
+          </a:p>
+        </p:txBody>
+      </p:sp>
+    </p:spTree>
+    <p:extLst>
+      <p:ext uri="{BB962C8B-B14F-4D97-AF65-F5344CB8AC3E}">
         <p14:creationId xmlns:p14="http://schemas.microsoft.com/office/powerpoint/2010/main" val="1829450983"/>
       </p:ext>
     </p:extLst>
@@ -2914,7 +3050,7 @@
 </p:notes>
 </file>
 
-<file path=ppt/notesSlides/notesSlide28.xml><?xml version="1.0" encoding="utf-8"?>
+<file path=ppt/notesSlides/notesSlide29.xml><?xml version="1.0" encoding="utf-8"?>
 <p:notes xmlns:a="http://schemas.openxmlformats.org/drawingml/2006/main" xmlns:r="http://schemas.openxmlformats.org/officeDocument/2006/relationships" xmlns:p="http://schemas.openxmlformats.org/presentationml/2006/main" showMasterSp="0" showMasterPhAnim="0">
   <p:cSld>
     <p:spTree>
@@ -4161,7 +4297,7 @@
             </a:pPr>
             <a:fld id="{00000000-1234-1234-1234-123412341234}" type="slidenum">
               <a:rPr lang="it"/>
-              <a:t>‹#›</a:t>
+              <a:t>‹N›</a:t>
             </a:fld>
             <a:endParaRPr/>
           </a:p>
@@ -4525,7 +4661,7 @@
             </a:pPr>
             <a:fld id="{00000000-1234-1234-1234-123412341234}" type="slidenum">
               <a:rPr lang="it"/>
-              <a:t>‹#›</a:t>
+              <a:t>‹N›</a:t>
             </a:fld>
             <a:endParaRPr/>
           </a:p>
@@ -4629,7 +4765,7 @@
             </a:pPr>
             <a:fld id="{00000000-1234-1234-1234-123412341234}" type="slidenum">
               <a:rPr lang="it"/>
-              <a:t>‹#›</a:t>
+              <a:t>‹N›</a:t>
             </a:fld>
             <a:endParaRPr/>
           </a:p>
@@ -4862,7 +4998,7 @@
             </a:pPr>
             <a:fld id="{00000000-1234-1234-1234-123412341234}" type="slidenum">
               <a:rPr lang="it"/>
-              <a:t>‹#›</a:t>
+              <a:t>‹N›</a:t>
             </a:fld>
             <a:endParaRPr/>
           </a:p>
@@ -5224,7 +5360,7 @@
             </a:pPr>
             <a:fld id="{00000000-1234-1234-1234-123412341234}" type="slidenum">
               <a:rPr lang="it"/>
-              <a:t>‹#›</a:t>
+              <a:t>‹N›</a:t>
             </a:fld>
             <a:endParaRPr/>
           </a:p>
@@ -5715,7 +5851,7 @@
             </a:pPr>
             <a:fld id="{00000000-1234-1234-1234-123412341234}" type="slidenum">
               <a:rPr lang="it"/>
-              <a:t>‹#›</a:t>
+              <a:t>‹N›</a:t>
             </a:fld>
             <a:endParaRPr/>
           </a:p>
@@ -5948,7 +6084,7 @@
             </a:pPr>
             <a:fld id="{00000000-1234-1234-1234-123412341234}" type="slidenum">
               <a:rPr lang="it"/>
-              <a:t>‹#›</a:t>
+              <a:t>‹N›</a:t>
             </a:fld>
             <a:endParaRPr/>
           </a:p>
@@ -6310,7 +6446,7 @@
             </a:pPr>
             <a:fld id="{00000000-1234-1234-1234-123412341234}" type="slidenum">
               <a:rPr lang="it"/>
-              <a:t>‹#›</a:t>
+              <a:t>‹N›</a:t>
             </a:fld>
             <a:endParaRPr/>
           </a:p>
@@ -6543,7 +6679,7 @@
             </a:pPr>
             <a:fld id="{00000000-1234-1234-1234-123412341234}" type="slidenum">
               <a:rPr lang="it"/>
-              <a:t>‹#›</a:t>
+              <a:t>‹N›</a:t>
             </a:fld>
             <a:endParaRPr/>
           </a:p>
@@ -7101,7 +7237,7 @@
             </a:pPr>
             <a:fld id="{00000000-1234-1234-1234-123412341234}" type="slidenum">
               <a:rPr lang="it"/>
-              <a:t>‹#›</a:t>
+              <a:t>‹N›</a:t>
             </a:fld>
             <a:endParaRPr/>
           </a:p>
@@ -7249,7 +7385,7 @@
             </a:pPr>
             <a:fld id="{00000000-1234-1234-1234-123412341234}" type="slidenum">
               <a:rPr lang="it"/>
-              <a:t>‹#›</a:t>
+              <a:t>‹N›</a:t>
             </a:fld>
             <a:endParaRPr/>
           </a:p>
@@ -7820,7 +7956,7 @@
             </a:pPr>
             <a:fld id="{00000000-1234-1234-1234-123412341234}" type="slidenum">
               <a:rPr lang="it"/>
-              <a:t>‹#›</a:t>
+              <a:t>‹N›</a:t>
             </a:fld>
             <a:endParaRPr/>
           </a:p>
@@ -15184,7 +15320,7 @@
                 <a:cs typeface="Times New Roman"/>
                 <a:sym typeface="Times New Roman"/>
               </a:rPr>
-              <a:t>20/27</a:t>
+              <a:t>21/27</a:t>
             </a:r>
             <a:endParaRPr dirty="0">
               <a:latin typeface="Times New Roman"/>
@@ -15223,10 +15359,10 @@
       </p:cxnSp>
       <p:pic>
         <p:nvPicPr>
-          <p:cNvPr id="3" name="Picture 2" descr="A table with numbers and text&#10;&#10;AI-generated content may be incorrect.">
+          <p:cNvPr id="4" name="Picture 3" descr="A blue squares with numbers&#10;&#10;AI-generated content may be incorrect.">
             <a:extLst>
               <a:ext uri="{FF2B5EF4-FFF2-40B4-BE49-F238E27FC236}">
-                <a16:creationId xmlns:a16="http://schemas.microsoft.com/office/drawing/2014/main" id="{B9786BB9-5803-876E-DDEB-90AF2C083B3F}"/>
+                <a16:creationId xmlns:a16="http://schemas.microsoft.com/office/drawing/2014/main" id="{46BA1B64-6D13-6C39-1ED3-6F061477EA14}"/>
               </a:ext>
             </a:extLst>
           </p:cNvPr>
@@ -15243,8 +15379,8 @@
         </p:blipFill>
         <p:spPr>
           <a:xfrm>
-            <a:off x="874934" y="1456985"/>
-            <a:ext cx="7394132" cy="2229529"/>
+            <a:off x="1534080" y="855828"/>
+            <a:ext cx="6075839" cy="4067665"/>
           </a:xfrm>
           <a:prstGeom prst="rect">
             <a:avLst/>
@@ -15254,7 +15390,7 @@
     </p:spTree>
     <p:extLst>
       <p:ext uri="{BB962C8B-B14F-4D97-AF65-F5344CB8AC3E}">
-        <p14:creationId xmlns:p14="http://schemas.microsoft.com/office/powerpoint/2010/main" val="1439281819"/>
+        <p14:creationId xmlns:p14="http://schemas.microsoft.com/office/powerpoint/2010/main" val="1279555456"/>
       </p:ext>
     </p:extLst>
   </p:cSld>
@@ -15375,7 +15511,7 @@
                 <a:cs typeface="Times New Roman"/>
                 <a:sym typeface="Times New Roman"/>
               </a:rPr>
-              <a:t>21/27</a:t>
+              <a:t>20/27</a:t>
             </a:r>
             <a:endParaRPr dirty="0">
               <a:latin typeface="Times New Roman"/>
@@ -15414,10 +15550,10 @@
       </p:cxnSp>
       <p:pic>
         <p:nvPicPr>
-          <p:cNvPr id="4" name="Picture 3" descr="A blue squares with numbers&#10;&#10;AI-generated content may be incorrect.">
+          <p:cNvPr id="3" name="Picture 2" descr="A table with numbers and text&#10;&#10;AI-generated content may be incorrect.">
             <a:extLst>
               <a:ext uri="{FF2B5EF4-FFF2-40B4-BE49-F238E27FC236}">
-                <a16:creationId xmlns:a16="http://schemas.microsoft.com/office/drawing/2014/main" id="{46BA1B64-6D13-6C39-1ED3-6F061477EA14}"/>
+                <a16:creationId xmlns:a16="http://schemas.microsoft.com/office/drawing/2014/main" id="{B9786BB9-5803-876E-DDEB-90AF2C083B3F}"/>
               </a:ext>
             </a:extLst>
           </p:cNvPr>
@@ -15434,8 +15570,8 @@
         </p:blipFill>
         <p:spPr>
           <a:xfrm>
-            <a:off x="1534080" y="855828"/>
-            <a:ext cx="6075839" cy="4067665"/>
+            <a:off x="874934" y="1456985"/>
+            <a:ext cx="7394132" cy="2229529"/>
           </a:xfrm>
           <a:prstGeom prst="rect">
             <a:avLst/>
@@ -15445,7 +15581,7 @@
     </p:spTree>
     <p:extLst>
       <p:ext uri="{BB962C8B-B14F-4D97-AF65-F5344CB8AC3E}">
-        <p14:creationId xmlns:p14="http://schemas.microsoft.com/office/powerpoint/2010/main" val="1279555456"/>
+        <p14:creationId xmlns:p14="http://schemas.microsoft.com/office/powerpoint/2010/main" val="1439281819"/>
       </p:ext>
     </p:extLst>
   </p:cSld>
@@ -16081,7 +16217,13 @@
   <p:cSld>
     <p:spTree>
       <p:nvGrpSpPr>
-        <p:cNvPr id="1" name="Shape 65"/>
+        <p:cNvPr id="1" name="Shape 65">
+          <a:extLst>
+            <a:ext uri="{FF2B5EF4-FFF2-40B4-BE49-F238E27FC236}">
+              <a16:creationId xmlns:a16="http://schemas.microsoft.com/office/drawing/2014/main" id="{A0D9977F-11AA-BE37-DF5D-FB8E75F26018}"/>
+            </a:ext>
+          </a:extLst>
+        </p:cNvPr>
         <p:cNvGrpSpPr/>
         <p:nvPr/>
       </p:nvGrpSpPr>
@@ -16095,7 +16237,13 @@
       </p:grpSpPr>
       <p:sp>
         <p:nvSpPr>
-          <p:cNvPr id="66" name="Google Shape;66;p14"/>
+          <p:cNvPr id="66" name="Google Shape;66;p14">
+            <a:extLst>
+              <a:ext uri="{FF2B5EF4-FFF2-40B4-BE49-F238E27FC236}">
+                <a16:creationId xmlns:a16="http://schemas.microsoft.com/office/drawing/2014/main" id="{B7120D5B-3ED6-2E4E-80E0-5AFD161FA948}"/>
+              </a:ext>
+            </a:extLst>
+          </p:cNvPr>
           <p:cNvSpPr txBox="1">
             <a:spLocks noGrp="1"/>
           </p:cNvSpPr>
@@ -16135,7 +16283,7 @@
                 <a:cs typeface="Roboto Serif"/>
                 <a:sym typeface="Roboto Serif"/>
               </a:rPr>
-              <a:t>Model explainability</a:t>
+              <a:t>LightGBM optimization</a:t>
             </a:r>
             <a:endParaRPr sz="3720" b="1" dirty="0">
               <a:latin typeface="Roboto Serif"/>
@@ -16148,211 +16296,13 @@
       </p:sp>
       <p:sp>
         <p:nvSpPr>
-          <p:cNvPr id="67" name="Google Shape;67;p14"/>
-          <p:cNvSpPr txBox="1">
-            <a:spLocks noGrp="1"/>
-          </p:cNvSpPr>
-          <p:nvPr>
-            <p:ph type="body" idx="1"/>
-          </p:nvPr>
-        </p:nvSpPr>
-        <p:spPr>
-          <a:xfrm>
-            <a:off x="346750" y="1138425"/>
-            <a:ext cx="8520600" cy="1989000"/>
-          </a:xfrm>
-          <a:prstGeom prst="rect">
-            <a:avLst/>
-          </a:prstGeom>
-        </p:spPr>
-        <p:txBody>
-          <a:bodyPr spcFirstLastPara="1" wrap="square" lIns="91425" tIns="91425" rIns="91425" bIns="91425" anchor="t" anchorCtr="0">
-            <a:noAutofit/>
-          </a:bodyPr>
-          <a:lstStyle/>
-          <a:p>
-            <a:pPr marL="457200" lvl="0" indent="-342900" algn="l" rtl="0">
-              <a:lnSpc>
-                <a:spcPct val="150000"/>
-              </a:lnSpc>
-              <a:spcBef>
-                <a:spcPts val="0"/>
-              </a:spcBef>
-              <a:spcAft>
-                <a:spcPts val="0"/>
-              </a:spcAft>
-              <a:buSzPts val="1800"/>
-              <a:buFont typeface="Times New Roman"/>
-              <a:buChar char="●"/>
-            </a:pPr>
-            <a:r>
-              <a:rPr lang="it-IT" sz="1700" b="1" dirty="0">
-                <a:latin typeface="Open Sans"/>
-                <a:ea typeface="Open Sans"/>
-                <a:cs typeface="Open Sans"/>
-                <a:sym typeface="Open Sans"/>
-              </a:rPr>
-              <a:t>The "Black Box" Problem</a:t>
-            </a:r>
-            <a:r>
-              <a:rPr lang="it-IT" sz="1700" dirty="0">
-                <a:latin typeface="Open Sans"/>
-                <a:ea typeface="Open Sans"/>
-                <a:cs typeface="Open Sans"/>
-                <a:sym typeface="Open Sans"/>
-              </a:rPr>
-              <a:t>: High performance requires transparency and trust.</a:t>
-            </a:r>
-          </a:p>
-          <a:p>
-            <a:pPr marL="457200" lvl="0" indent="-342900" algn="l" rtl="0">
-              <a:lnSpc>
-                <a:spcPct val="150000"/>
-              </a:lnSpc>
-              <a:spcBef>
-                <a:spcPts val="0"/>
-              </a:spcBef>
-              <a:spcAft>
-                <a:spcPts val="0"/>
-              </a:spcAft>
-              <a:buSzPts val="1800"/>
-              <a:buFont typeface="Times New Roman"/>
-              <a:buChar char="●"/>
-            </a:pPr>
-            <a:r>
-              <a:rPr lang="it-IT" sz="1700" b="1" dirty="0">
-                <a:latin typeface="Open Sans"/>
-                <a:ea typeface="Open Sans"/>
-                <a:cs typeface="Open Sans"/>
-                <a:sym typeface="Open Sans"/>
-              </a:rPr>
-              <a:t>Global Interpretation (SHAP)</a:t>
-            </a:r>
-            <a:r>
-              <a:rPr lang="it-IT" sz="1700" dirty="0">
-                <a:latin typeface="Open Sans"/>
-                <a:ea typeface="Open Sans"/>
-                <a:cs typeface="Open Sans"/>
-                <a:sym typeface="Open Sans"/>
-              </a:rPr>
-              <a:t>:</a:t>
-            </a:r>
-            <a:r>
-              <a:rPr lang="it-IT" sz="1700" b="1" dirty="0">
-                <a:latin typeface="Open Sans"/>
-                <a:ea typeface="Open Sans"/>
-                <a:cs typeface="Open Sans"/>
-                <a:sym typeface="Open Sans"/>
-              </a:rPr>
-              <a:t> </a:t>
-            </a:r>
-            <a:r>
-              <a:rPr lang="it-IT" sz="1700" dirty="0">
-                <a:latin typeface="Open Sans"/>
-                <a:ea typeface="Open Sans"/>
-                <a:cs typeface="Open Sans"/>
-                <a:sym typeface="Open Sans"/>
-              </a:rPr>
-              <a:t>Identifies the most impactful features across the entire dataset (e.g., specific keywords, exclamation ratio).</a:t>
-            </a:r>
-          </a:p>
-          <a:p>
-            <a:pPr marL="457200" lvl="0" indent="-342900" algn="l" rtl="0">
-              <a:lnSpc>
-                <a:spcPct val="150000"/>
-              </a:lnSpc>
-              <a:spcBef>
-                <a:spcPts val="0"/>
-              </a:spcBef>
-              <a:spcAft>
-                <a:spcPts val="0"/>
-              </a:spcAft>
-              <a:buSzPts val="1800"/>
-              <a:buFont typeface="Times New Roman"/>
-              <a:buChar char="●"/>
-            </a:pPr>
-            <a:r>
-              <a:rPr lang="it-IT" sz="1700" b="1" dirty="0">
-                <a:latin typeface="Open Sans"/>
-                <a:ea typeface="Open Sans"/>
-                <a:cs typeface="Open Sans"/>
-                <a:sym typeface="Open Sans"/>
-              </a:rPr>
-              <a:t>Local Interpretation (LIME)</a:t>
-            </a:r>
-            <a:r>
-              <a:rPr lang="it-IT" sz="1700" dirty="0">
-                <a:latin typeface="Open Sans"/>
-                <a:ea typeface="Open Sans"/>
-                <a:cs typeface="Open Sans"/>
-                <a:sym typeface="Open Sans"/>
-              </a:rPr>
-              <a:t>:</a:t>
-            </a:r>
-            <a:r>
-              <a:rPr lang="it-IT" sz="1700" b="1" dirty="0">
-                <a:latin typeface="Open Sans"/>
-                <a:ea typeface="Open Sans"/>
-                <a:cs typeface="Open Sans"/>
-                <a:sym typeface="Open Sans"/>
-              </a:rPr>
-              <a:t> </a:t>
-            </a:r>
-            <a:r>
-              <a:rPr lang="it-IT" sz="1700" dirty="0">
-                <a:latin typeface="Open Sans"/>
-                <a:ea typeface="Open Sans"/>
-                <a:cs typeface="Open Sans"/>
-                <a:sym typeface="Open Sans"/>
-              </a:rPr>
-              <a:t>Explains single, real-time predictions to the end-user.</a:t>
-            </a:r>
-          </a:p>
-          <a:p>
-            <a:pPr marL="457200" lvl="0" indent="-342900" algn="l" rtl="0">
-              <a:lnSpc>
-                <a:spcPct val="150000"/>
-              </a:lnSpc>
-              <a:spcBef>
-                <a:spcPts val="0"/>
-              </a:spcBef>
-              <a:spcAft>
-                <a:spcPts val="0"/>
-              </a:spcAft>
-              <a:buSzPts val="1800"/>
-              <a:buFont typeface="Times New Roman"/>
-              <a:buChar char="●"/>
-            </a:pPr>
-            <a:r>
-              <a:rPr lang="it-IT" sz="1700" b="1" dirty="0">
-                <a:latin typeface="Open Sans"/>
-                <a:ea typeface="Open Sans"/>
-                <a:cs typeface="Open Sans"/>
-                <a:sym typeface="Open Sans"/>
-              </a:rPr>
-              <a:t>Our Strategy</a:t>
-            </a:r>
-            <a:r>
-              <a:rPr lang="it-IT" sz="1700" dirty="0">
-                <a:latin typeface="Open Sans"/>
-                <a:ea typeface="Open Sans"/>
-                <a:cs typeface="Open Sans"/>
-                <a:sym typeface="Open Sans"/>
-              </a:rPr>
-              <a:t>: SHAP for model validation, LIME for user-facing transparency.</a:t>
-            </a:r>
-            <a:endParaRPr sz="1700" dirty="0">
-              <a:latin typeface="Open Sans"/>
-              <a:ea typeface="Open Sans"/>
-              <a:cs typeface="Open Sans"/>
-              <a:sym typeface="Open Sans"/>
-            </a:endParaRPr>
-          </a:p>
-        </p:txBody>
-      </p:sp>
-      <p:sp>
-        <p:nvSpPr>
-          <p:cNvPr id="68" name="Google Shape;68;p14"/>
+          <p:cNvPr id="68" name="Google Shape;68;p14">
+            <a:extLst>
+              <a:ext uri="{FF2B5EF4-FFF2-40B4-BE49-F238E27FC236}">
+                <a16:creationId xmlns:a16="http://schemas.microsoft.com/office/drawing/2014/main" id="{D288080E-5E15-83AD-B0A7-8BF0333130E9}"/>
+              </a:ext>
+            </a:extLst>
+          </p:cNvPr>
           <p:cNvSpPr txBox="1">
             <a:spLocks noGrp="1"/>
           </p:cNvSpPr>
@@ -16391,7 +16341,7 @@
                 <a:cs typeface="Times New Roman"/>
                 <a:sym typeface="Times New Roman"/>
               </a:rPr>
-              <a:t>24/27</a:t>
+              <a:t>22/27</a:t>
             </a:r>
             <a:endParaRPr dirty="0">
               <a:latin typeface="Times New Roman"/>
@@ -16404,7 +16354,13 @@
       </p:sp>
       <p:cxnSp>
         <p:nvCxnSpPr>
-          <p:cNvPr id="69" name="Google Shape;69;p14"/>
+          <p:cNvPr id="69" name="Google Shape;69;p14">
+            <a:extLst>
+              <a:ext uri="{FF2B5EF4-FFF2-40B4-BE49-F238E27FC236}">
+                <a16:creationId xmlns:a16="http://schemas.microsoft.com/office/drawing/2014/main" id="{271CC5C2-AC57-EFC9-C9B8-841E39065A8D}"/>
+              </a:ext>
+            </a:extLst>
+          </p:cNvPr>
           <p:cNvCxnSpPr/>
           <p:nvPr/>
         </p:nvCxnSpPr>
@@ -16428,10 +16384,458 @@
           </a:ln>
         </p:spPr>
       </p:cxnSp>
+      <p:pic>
+        <p:nvPicPr>
+          <p:cNvPr id="4" name="Immagine 3" descr="Immagine che contiene testo, schermata, Carattere&#10;&#10;Il contenuto generato dall&amp;#39;IA potrebbe non essere corretto.">
+            <a:extLst>
+              <a:ext uri="{FF2B5EF4-FFF2-40B4-BE49-F238E27FC236}">
+                <a16:creationId xmlns:a16="http://schemas.microsoft.com/office/drawing/2014/main" id="{E0D9DE49-A140-9676-08F3-777C14D9C1E4}"/>
+              </a:ext>
+            </a:extLst>
+          </p:cNvPr>
+          <p:cNvPicPr>
+            <a:picLocks noChangeAspect="1"/>
+          </p:cNvPicPr>
+          <p:nvPr/>
+        </p:nvPicPr>
+        <p:blipFill>
+          <a:blip r:embed="rId3"/>
+          <a:srcRect r="205" b="19635"/>
+          <a:stretch>
+            <a:fillRect/>
+          </a:stretch>
+        </p:blipFill>
+        <p:spPr>
+          <a:xfrm>
+            <a:off x="2549569" y="1409178"/>
+            <a:ext cx="3802179" cy="1377863"/>
+          </a:xfrm>
+          <a:prstGeom prst="rect">
+            <a:avLst/>
+          </a:prstGeom>
+        </p:spPr>
+      </p:pic>
+      <p:pic>
+        <p:nvPicPr>
+          <p:cNvPr id="5" name="Immagine 4" descr="Immagine che contiene testo, schermata, Carattere&#10;&#10;Il contenuto generato dall&amp;#39;IA potrebbe non essere corretto.">
+            <a:extLst>
+              <a:ext uri="{FF2B5EF4-FFF2-40B4-BE49-F238E27FC236}">
+                <a16:creationId xmlns:a16="http://schemas.microsoft.com/office/drawing/2014/main" id="{7597DA4F-72BC-88FC-3A84-614970C6BDBD}"/>
+              </a:ext>
+            </a:extLst>
+          </p:cNvPr>
+          <p:cNvPicPr>
+            <a:picLocks noChangeAspect="1"/>
+          </p:cNvPicPr>
+          <p:nvPr/>
+        </p:nvPicPr>
+        <p:blipFill>
+          <a:blip r:embed="rId4"/>
+          <a:srcRect r="-140" b="22868"/>
+          <a:stretch>
+            <a:fillRect/>
+          </a:stretch>
+        </p:blipFill>
+        <p:spPr>
+          <a:xfrm>
+            <a:off x="1278438" y="3276601"/>
+            <a:ext cx="5608534" cy="1557523"/>
+          </a:xfrm>
+          <a:prstGeom prst="rect">
+            <a:avLst/>
+          </a:prstGeom>
+        </p:spPr>
+      </p:pic>
+      <p:sp>
+        <p:nvSpPr>
+          <p:cNvPr id="7" name="Google Shape;67;p14">
+            <a:extLst>
+              <a:ext uri="{FF2B5EF4-FFF2-40B4-BE49-F238E27FC236}">
+                <a16:creationId xmlns:a16="http://schemas.microsoft.com/office/drawing/2014/main" id="{3FCA567D-E1B1-A190-4106-41D3150BCFA4}"/>
+              </a:ext>
+            </a:extLst>
+          </p:cNvPr>
+          <p:cNvSpPr txBox="1">
+            <a:spLocks noGrp="1"/>
+          </p:cNvSpPr>
+          <p:nvPr>
+            <p:ph type="body" idx="1"/>
+          </p:nvPr>
+        </p:nvSpPr>
+        <p:spPr>
+          <a:xfrm>
+            <a:off x="2491832" y="1013165"/>
+            <a:ext cx="3651107" cy="673768"/>
+          </a:xfrm>
+          <a:prstGeom prst="rect">
+            <a:avLst/>
+          </a:prstGeom>
+        </p:spPr>
+        <p:txBody>
+          <a:bodyPr spcFirstLastPara="1" wrap="square" lIns="91425" tIns="91425" rIns="91425" bIns="91425" anchor="t" anchorCtr="0">
+            <a:normAutofit fontScale="92500"/>
+          </a:bodyPr>
+          <a:lstStyle/>
+          <a:p>
+            <a:pPr marL="114300" indent="0">
+              <a:lnSpc>
+                <a:spcPct val="150000"/>
+              </a:lnSpc>
+              <a:buNone/>
+            </a:pPr>
+            <a:r>
+              <a:rPr lang="it-IT" sz="1400" dirty="0" err="1">
+                <a:latin typeface="Open Sans"/>
+                <a:ea typeface="Open Sans"/>
+                <a:cs typeface="Open Sans"/>
+              </a:rPr>
+              <a:t>Before</a:t>
+            </a:r>
+            <a:r>
+              <a:rPr lang="it-IT" sz="1400" dirty="0">
+                <a:latin typeface="Open Sans"/>
+                <a:ea typeface="Open Sans"/>
+                <a:cs typeface="Open Sans"/>
+              </a:rPr>
+              <a:t> </a:t>
+            </a:r>
+            <a:r>
+              <a:rPr lang="it-IT" sz="1400" dirty="0" err="1">
+                <a:latin typeface="Open Sans"/>
+                <a:ea typeface="Open Sans"/>
+                <a:cs typeface="Open Sans"/>
+              </a:rPr>
+              <a:t>Hyperparameter</a:t>
+            </a:r>
+            <a:r>
+              <a:rPr lang="it-IT" sz="1400" dirty="0">
+                <a:latin typeface="Open Sans"/>
+                <a:ea typeface="Open Sans"/>
+                <a:cs typeface="Open Sans"/>
+              </a:rPr>
+              <a:t> Tuning (Test set)</a:t>
+            </a:r>
+            <a:endParaRPr lang="it-IT" sz="1400" dirty="0"/>
+          </a:p>
+        </p:txBody>
+      </p:sp>
+      <p:sp>
+        <p:nvSpPr>
+          <p:cNvPr id="10" name="Google Shape;67;p14">
+            <a:extLst>
+              <a:ext uri="{FF2B5EF4-FFF2-40B4-BE49-F238E27FC236}">
+                <a16:creationId xmlns:a16="http://schemas.microsoft.com/office/drawing/2014/main" id="{DEFFD00A-913E-36BA-15C1-A037A28E91E9}"/>
+              </a:ext>
+            </a:extLst>
+          </p:cNvPr>
+          <p:cNvSpPr txBox="1">
+            <a:spLocks/>
+          </p:cNvSpPr>
+          <p:nvPr/>
+        </p:nvSpPr>
+        <p:spPr>
+          <a:xfrm>
+            <a:off x="2487658" y="2942695"/>
+            <a:ext cx="3651107" cy="673768"/>
+          </a:xfrm>
+          <a:prstGeom prst="rect">
+            <a:avLst/>
+          </a:prstGeom>
+          <a:noFill/>
+          <a:ln>
+            <a:noFill/>
+          </a:ln>
+        </p:spPr>
+        <p:txBody>
+          <a:bodyPr spcFirstLastPara="1" wrap="square" lIns="91425" tIns="91425" rIns="91425" bIns="91425" anchor="t" anchorCtr="0">
+            <a:normAutofit/>
+          </a:bodyPr>
+          <a:lstStyle>
+            <a:defPPr marR="0" lvl="0" algn="l" rtl="0">
+              <a:lnSpc>
+                <a:spcPct val="100000"/>
+              </a:lnSpc>
+              <a:spcBef>
+                <a:spcPts val="0"/>
+              </a:spcBef>
+              <a:spcAft>
+                <a:spcPts val="0"/>
+              </a:spcAft>
+            </a:defPPr>
+            <a:lvl1pPr marL="457200" marR="0" lvl="0" indent="-342900" algn="l" rtl="0">
+              <a:lnSpc>
+                <a:spcPct val="115000"/>
+              </a:lnSpc>
+              <a:spcBef>
+                <a:spcPts val="0"/>
+              </a:spcBef>
+              <a:spcAft>
+                <a:spcPts val="0"/>
+              </a:spcAft>
+              <a:buClr>
+                <a:schemeClr val="dk2"/>
+              </a:buClr>
+              <a:buSzPts val="1800"/>
+              <a:buFont typeface="Arial"/>
+              <a:buChar char="●"/>
+              <a:defRPr sz="1800" b="0" i="0" u="none" strike="noStrike" cap="none">
+                <a:solidFill>
+                  <a:schemeClr val="dk2"/>
+                </a:solidFill>
+                <a:latin typeface="Arial"/>
+                <a:ea typeface="Arial"/>
+                <a:cs typeface="Arial"/>
+                <a:sym typeface="Arial"/>
+              </a:defRPr>
+            </a:lvl1pPr>
+            <a:lvl2pPr marL="914400" marR="0" lvl="1" indent="-317500" algn="l" rtl="0">
+              <a:lnSpc>
+                <a:spcPct val="115000"/>
+              </a:lnSpc>
+              <a:spcBef>
+                <a:spcPts val="0"/>
+              </a:spcBef>
+              <a:spcAft>
+                <a:spcPts val="0"/>
+              </a:spcAft>
+              <a:buClr>
+                <a:schemeClr val="dk2"/>
+              </a:buClr>
+              <a:buSzPts val="1400"/>
+              <a:buFont typeface="Arial"/>
+              <a:buChar char="○"/>
+              <a:defRPr sz="1400" b="0" i="0" u="none" strike="noStrike" cap="none">
+                <a:solidFill>
+                  <a:schemeClr val="dk2"/>
+                </a:solidFill>
+                <a:latin typeface="Arial"/>
+                <a:ea typeface="Arial"/>
+                <a:cs typeface="Arial"/>
+                <a:sym typeface="Arial"/>
+              </a:defRPr>
+            </a:lvl2pPr>
+            <a:lvl3pPr marL="1371600" marR="0" lvl="2" indent="-317500" algn="l" rtl="0">
+              <a:lnSpc>
+                <a:spcPct val="115000"/>
+              </a:lnSpc>
+              <a:spcBef>
+                <a:spcPts val="0"/>
+              </a:spcBef>
+              <a:spcAft>
+                <a:spcPts val="0"/>
+              </a:spcAft>
+              <a:buClr>
+                <a:schemeClr val="dk2"/>
+              </a:buClr>
+              <a:buSzPts val="1400"/>
+              <a:buFont typeface="Arial"/>
+              <a:buChar char="■"/>
+              <a:defRPr sz="1400" b="0" i="0" u="none" strike="noStrike" cap="none">
+                <a:solidFill>
+                  <a:schemeClr val="dk2"/>
+                </a:solidFill>
+                <a:latin typeface="Arial"/>
+                <a:ea typeface="Arial"/>
+                <a:cs typeface="Arial"/>
+                <a:sym typeface="Arial"/>
+              </a:defRPr>
+            </a:lvl3pPr>
+            <a:lvl4pPr marL="1828800" marR="0" lvl="3" indent="-317500" algn="l" rtl="0">
+              <a:lnSpc>
+                <a:spcPct val="115000"/>
+              </a:lnSpc>
+              <a:spcBef>
+                <a:spcPts val="0"/>
+              </a:spcBef>
+              <a:spcAft>
+                <a:spcPts val="0"/>
+              </a:spcAft>
+              <a:buClr>
+                <a:schemeClr val="dk2"/>
+              </a:buClr>
+              <a:buSzPts val="1400"/>
+              <a:buFont typeface="Arial"/>
+              <a:buChar char="●"/>
+              <a:defRPr sz="1400" b="0" i="0" u="none" strike="noStrike" cap="none">
+                <a:solidFill>
+                  <a:schemeClr val="dk2"/>
+                </a:solidFill>
+                <a:latin typeface="Arial"/>
+                <a:ea typeface="Arial"/>
+                <a:cs typeface="Arial"/>
+                <a:sym typeface="Arial"/>
+              </a:defRPr>
+            </a:lvl4pPr>
+            <a:lvl5pPr marL="2286000" marR="0" lvl="4" indent="-317500" algn="l" rtl="0">
+              <a:lnSpc>
+                <a:spcPct val="115000"/>
+              </a:lnSpc>
+              <a:spcBef>
+                <a:spcPts val="0"/>
+              </a:spcBef>
+              <a:spcAft>
+                <a:spcPts val="0"/>
+              </a:spcAft>
+              <a:buClr>
+                <a:schemeClr val="dk2"/>
+              </a:buClr>
+              <a:buSzPts val="1400"/>
+              <a:buFont typeface="Arial"/>
+              <a:buChar char="○"/>
+              <a:defRPr sz="1400" b="0" i="0" u="none" strike="noStrike" cap="none">
+                <a:solidFill>
+                  <a:schemeClr val="dk2"/>
+                </a:solidFill>
+                <a:latin typeface="Arial"/>
+                <a:ea typeface="Arial"/>
+                <a:cs typeface="Arial"/>
+                <a:sym typeface="Arial"/>
+              </a:defRPr>
+            </a:lvl5pPr>
+            <a:lvl6pPr marL="2743200" marR="0" lvl="5" indent="-317500" algn="l" rtl="0">
+              <a:lnSpc>
+                <a:spcPct val="115000"/>
+              </a:lnSpc>
+              <a:spcBef>
+                <a:spcPts val="0"/>
+              </a:spcBef>
+              <a:spcAft>
+                <a:spcPts val="0"/>
+              </a:spcAft>
+              <a:buClr>
+                <a:schemeClr val="dk2"/>
+              </a:buClr>
+              <a:buSzPts val="1400"/>
+              <a:buFont typeface="Arial"/>
+              <a:buChar char="■"/>
+              <a:defRPr sz="1400" b="0" i="0" u="none" strike="noStrike" cap="none">
+                <a:solidFill>
+                  <a:schemeClr val="dk2"/>
+                </a:solidFill>
+                <a:latin typeface="Arial"/>
+                <a:ea typeface="Arial"/>
+                <a:cs typeface="Arial"/>
+                <a:sym typeface="Arial"/>
+              </a:defRPr>
+            </a:lvl6pPr>
+            <a:lvl7pPr marL="3200400" marR="0" lvl="6" indent="-317500" algn="l" rtl="0">
+              <a:lnSpc>
+                <a:spcPct val="115000"/>
+              </a:lnSpc>
+              <a:spcBef>
+                <a:spcPts val="0"/>
+              </a:spcBef>
+              <a:spcAft>
+                <a:spcPts val="0"/>
+              </a:spcAft>
+              <a:buClr>
+                <a:schemeClr val="dk2"/>
+              </a:buClr>
+              <a:buSzPts val="1400"/>
+              <a:buFont typeface="Arial"/>
+              <a:buChar char="●"/>
+              <a:defRPr sz="1400" b="0" i="0" u="none" strike="noStrike" cap="none">
+                <a:solidFill>
+                  <a:schemeClr val="dk2"/>
+                </a:solidFill>
+                <a:latin typeface="Arial"/>
+                <a:ea typeface="Arial"/>
+                <a:cs typeface="Arial"/>
+                <a:sym typeface="Arial"/>
+              </a:defRPr>
+            </a:lvl7pPr>
+            <a:lvl8pPr marL="3657600" marR="0" lvl="7" indent="-317500" algn="l" rtl="0">
+              <a:lnSpc>
+                <a:spcPct val="115000"/>
+              </a:lnSpc>
+              <a:spcBef>
+                <a:spcPts val="0"/>
+              </a:spcBef>
+              <a:spcAft>
+                <a:spcPts val="0"/>
+              </a:spcAft>
+              <a:buClr>
+                <a:schemeClr val="dk2"/>
+              </a:buClr>
+              <a:buSzPts val="1400"/>
+              <a:buFont typeface="Arial"/>
+              <a:buChar char="○"/>
+              <a:defRPr sz="1400" b="0" i="0" u="none" strike="noStrike" cap="none">
+                <a:solidFill>
+                  <a:schemeClr val="dk2"/>
+                </a:solidFill>
+                <a:latin typeface="Arial"/>
+                <a:ea typeface="Arial"/>
+                <a:cs typeface="Arial"/>
+                <a:sym typeface="Arial"/>
+              </a:defRPr>
+            </a:lvl8pPr>
+            <a:lvl9pPr marL="4114800" marR="0" lvl="8" indent="-317500" algn="l" rtl="0">
+              <a:lnSpc>
+                <a:spcPct val="115000"/>
+              </a:lnSpc>
+              <a:spcBef>
+                <a:spcPts val="0"/>
+              </a:spcBef>
+              <a:spcAft>
+                <a:spcPts val="0"/>
+              </a:spcAft>
+              <a:buClr>
+                <a:schemeClr val="dk2"/>
+              </a:buClr>
+              <a:buSzPts val="1400"/>
+              <a:buFont typeface="Arial"/>
+              <a:buChar char="■"/>
+              <a:defRPr sz="1400" b="0" i="0" u="none" strike="noStrike" cap="none">
+                <a:solidFill>
+                  <a:schemeClr val="dk2"/>
+                </a:solidFill>
+                <a:latin typeface="Arial"/>
+                <a:ea typeface="Arial"/>
+                <a:cs typeface="Arial"/>
+                <a:sym typeface="Arial"/>
+              </a:defRPr>
+            </a:lvl9pPr>
+          </a:lstStyle>
+          <a:p>
+            <a:pPr marL="114300" indent="0">
+              <a:lnSpc>
+                <a:spcPct val="150000"/>
+              </a:lnSpc>
+              <a:buNone/>
+            </a:pPr>
+            <a:r>
+              <a:rPr lang="it-IT" sz="1400" dirty="0">
+                <a:latin typeface="Open Sans"/>
+                <a:ea typeface="Open Sans"/>
+                <a:cs typeface="Open Sans"/>
+              </a:rPr>
+              <a:t>After </a:t>
+            </a:r>
+            <a:r>
+              <a:rPr lang="it-IT" sz="1400" dirty="0" err="1">
+                <a:latin typeface="Open Sans"/>
+                <a:ea typeface="Open Sans"/>
+                <a:cs typeface="Open Sans"/>
+              </a:rPr>
+              <a:t>Hyperparameter</a:t>
+            </a:r>
+            <a:r>
+              <a:rPr lang="it-IT" sz="1400" dirty="0">
+                <a:latin typeface="Open Sans"/>
+                <a:ea typeface="Open Sans"/>
+                <a:cs typeface="Open Sans"/>
+              </a:rPr>
+              <a:t> Tuning (Test set)</a:t>
+            </a:r>
+            <a:endParaRPr lang="it-IT" sz="1400" dirty="0"/>
+          </a:p>
+        </p:txBody>
+      </p:sp>
     </p:spTree>
     <p:extLst>
       <p:ext uri="{BB962C8B-B14F-4D97-AF65-F5344CB8AC3E}">
-        <p14:creationId xmlns:p14="http://schemas.microsoft.com/office/powerpoint/2010/main" val="779754174"/>
+        <p14:creationId xmlns:p14="http://schemas.microsoft.com/office/powerpoint/2010/main" val="2911178519"/>
       </p:ext>
     </p:extLst>
   </p:cSld>
@@ -16513,6 +16917,210 @@
       </p:sp>
       <p:sp>
         <p:nvSpPr>
+          <p:cNvPr id="67" name="Google Shape;67;p14"/>
+          <p:cNvSpPr txBox="1">
+            <a:spLocks noGrp="1"/>
+          </p:cNvSpPr>
+          <p:nvPr>
+            <p:ph type="body" idx="1"/>
+          </p:nvPr>
+        </p:nvSpPr>
+        <p:spPr>
+          <a:xfrm>
+            <a:off x="346750" y="1138425"/>
+            <a:ext cx="8520600" cy="1989000"/>
+          </a:xfrm>
+          <a:prstGeom prst="rect">
+            <a:avLst/>
+          </a:prstGeom>
+        </p:spPr>
+        <p:txBody>
+          <a:bodyPr spcFirstLastPara="1" wrap="square" lIns="91425" tIns="91425" rIns="91425" bIns="91425" anchor="t" anchorCtr="0">
+            <a:noAutofit/>
+          </a:bodyPr>
+          <a:lstStyle/>
+          <a:p>
+            <a:pPr marL="457200" lvl="0" indent="-342900" algn="l" rtl="0">
+              <a:lnSpc>
+                <a:spcPct val="150000"/>
+              </a:lnSpc>
+              <a:spcBef>
+                <a:spcPts val="0"/>
+              </a:spcBef>
+              <a:spcAft>
+                <a:spcPts val="0"/>
+              </a:spcAft>
+              <a:buSzPts val="1800"/>
+              <a:buFont typeface="Times New Roman"/>
+              <a:buChar char="●"/>
+            </a:pPr>
+            <a:r>
+              <a:rPr lang="it-IT" sz="1700" b="1" dirty="0">
+                <a:latin typeface="Open Sans"/>
+                <a:ea typeface="Open Sans"/>
+                <a:cs typeface="Open Sans"/>
+                <a:sym typeface="Open Sans"/>
+              </a:rPr>
+              <a:t>The "Black Box" Problem</a:t>
+            </a:r>
+            <a:r>
+              <a:rPr lang="it-IT" sz="1700" dirty="0">
+                <a:latin typeface="Open Sans"/>
+                <a:ea typeface="Open Sans"/>
+                <a:cs typeface="Open Sans"/>
+                <a:sym typeface="Open Sans"/>
+              </a:rPr>
+              <a:t>: High performance requires transparency and trust.</a:t>
+            </a:r>
+          </a:p>
+          <a:p>
+            <a:pPr marL="457200" lvl="0" indent="-342900" algn="l" rtl="0">
+              <a:lnSpc>
+                <a:spcPct val="150000"/>
+              </a:lnSpc>
+              <a:spcBef>
+                <a:spcPts val="0"/>
+              </a:spcBef>
+              <a:spcAft>
+                <a:spcPts val="0"/>
+              </a:spcAft>
+              <a:buSzPts val="1800"/>
+              <a:buFont typeface="Times New Roman"/>
+              <a:buChar char="●"/>
+            </a:pPr>
+            <a:r>
+              <a:rPr lang="it-IT" sz="1700" b="1" dirty="0">
+                <a:latin typeface="Open Sans"/>
+                <a:ea typeface="Open Sans"/>
+                <a:cs typeface="Open Sans"/>
+                <a:sym typeface="Open Sans"/>
+              </a:rPr>
+              <a:t>Global Interpretation (SHAP)</a:t>
+            </a:r>
+            <a:r>
+              <a:rPr lang="it-IT" sz="1700" dirty="0">
+                <a:latin typeface="Open Sans"/>
+                <a:ea typeface="Open Sans"/>
+                <a:cs typeface="Open Sans"/>
+                <a:sym typeface="Open Sans"/>
+              </a:rPr>
+              <a:t>:</a:t>
+            </a:r>
+            <a:r>
+              <a:rPr lang="it-IT" sz="1700" b="1" dirty="0">
+                <a:latin typeface="Open Sans"/>
+                <a:ea typeface="Open Sans"/>
+                <a:cs typeface="Open Sans"/>
+                <a:sym typeface="Open Sans"/>
+              </a:rPr>
+              <a:t> </a:t>
+            </a:r>
+            <a:r>
+              <a:rPr lang="it-IT" sz="1700" dirty="0">
+                <a:latin typeface="Open Sans"/>
+                <a:ea typeface="Open Sans"/>
+                <a:cs typeface="Open Sans"/>
+                <a:sym typeface="Open Sans"/>
+              </a:rPr>
+              <a:t>Identifies the most impactful features across the entire dataset (e.g., specific keywords, exclamation ratio).</a:t>
+            </a:r>
+          </a:p>
+          <a:p>
+            <a:pPr marL="457200" lvl="0" indent="-342900" algn="l" rtl="0">
+              <a:lnSpc>
+                <a:spcPct val="150000"/>
+              </a:lnSpc>
+              <a:spcBef>
+                <a:spcPts val="0"/>
+              </a:spcBef>
+              <a:spcAft>
+                <a:spcPts val="0"/>
+              </a:spcAft>
+              <a:buSzPts val="1800"/>
+              <a:buFont typeface="Times New Roman"/>
+              <a:buChar char="●"/>
+            </a:pPr>
+            <a:r>
+              <a:rPr lang="it-IT" sz="1700" b="1" dirty="0">
+                <a:latin typeface="Open Sans"/>
+                <a:ea typeface="Open Sans"/>
+                <a:cs typeface="Open Sans"/>
+                <a:sym typeface="Open Sans"/>
+              </a:rPr>
+              <a:t>Local Interpretation (LIME)</a:t>
+            </a:r>
+            <a:r>
+              <a:rPr lang="it-IT" sz="1700" dirty="0">
+                <a:latin typeface="Open Sans"/>
+                <a:ea typeface="Open Sans"/>
+                <a:cs typeface="Open Sans"/>
+                <a:sym typeface="Open Sans"/>
+              </a:rPr>
+              <a:t>:</a:t>
+            </a:r>
+            <a:r>
+              <a:rPr lang="it-IT" sz="1700" b="1" dirty="0">
+                <a:latin typeface="Open Sans"/>
+                <a:ea typeface="Open Sans"/>
+                <a:cs typeface="Open Sans"/>
+                <a:sym typeface="Open Sans"/>
+              </a:rPr>
+              <a:t> </a:t>
+            </a:r>
+            <a:r>
+              <a:rPr lang="it-IT" sz="1700" dirty="0">
+                <a:latin typeface="Open Sans"/>
+                <a:ea typeface="Open Sans"/>
+                <a:cs typeface="Open Sans"/>
+                <a:sym typeface="Open Sans"/>
+              </a:rPr>
+              <a:t>Explains single, real-time predictions to the end-user.</a:t>
+            </a:r>
+          </a:p>
+          <a:p>
+            <a:pPr marL="457200" lvl="0" indent="-342900" algn="l" rtl="0">
+              <a:lnSpc>
+                <a:spcPct val="150000"/>
+              </a:lnSpc>
+              <a:spcBef>
+                <a:spcPts val="0"/>
+              </a:spcBef>
+              <a:spcAft>
+                <a:spcPts val="0"/>
+              </a:spcAft>
+              <a:buSzPts val="1800"/>
+              <a:buFont typeface="Times New Roman"/>
+              <a:buChar char="●"/>
+            </a:pPr>
+            <a:r>
+              <a:rPr lang="it-IT" sz="1700" b="1" dirty="0">
+                <a:latin typeface="Open Sans"/>
+                <a:ea typeface="Open Sans"/>
+                <a:cs typeface="Open Sans"/>
+                <a:sym typeface="Open Sans"/>
+              </a:rPr>
+              <a:t>Our Strategy</a:t>
+            </a:r>
+            <a:r>
+              <a:rPr lang="it-IT" sz="1700" dirty="0">
+                <a:latin typeface="Open Sans"/>
+                <a:ea typeface="Open Sans"/>
+                <a:cs typeface="Open Sans"/>
+                <a:sym typeface="Open Sans"/>
+              </a:rPr>
+              <a:t>: SHAP for model validation, LIME for user-facing transparency.</a:t>
+            </a:r>
+            <a:endParaRPr sz="1700" dirty="0">
+              <a:latin typeface="Open Sans"/>
+              <a:ea typeface="Open Sans"/>
+              <a:cs typeface="Open Sans"/>
+              <a:sym typeface="Open Sans"/>
+            </a:endParaRPr>
+          </a:p>
+        </p:txBody>
+      </p:sp>
+      <p:sp>
+        <p:nvSpPr>
           <p:cNvPr id="68" name="Google Shape;68;p14"/>
           <p:cNvSpPr txBox="1">
             <a:spLocks noGrp="1"/>
@@ -16552,7 +17160,7 @@
                 <a:cs typeface="Times New Roman"/>
                 <a:sym typeface="Times New Roman"/>
               </a:rPr>
-              <a:t>25/27</a:t>
+              <a:t>24/27</a:t>
             </a:r>
             <a:endParaRPr dirty="0">
               <a:latin typeface="Times New Roman"/>
@@ -16589,186 +17197,10 @@
           </a:ln>
         </p:spPr>
       </p:cxnSp>
-      <p:pic>
-        <p:nvPicPr>
-          <p:cNvPr id="5" name="Picture 4" descr="A graph with numbers and text&#10;&#10;AI-generated content may be incorrect.">
-            <a:extLst>
-              <a:ext uri="{FF2B5EF4-FFF2-40B4-BE49-F238E27FC236}">
-                <a16:creationId xmlns:a16="http://schemas.microsoft.com/office/drawing/2014/main" id="{AD0649EA-B411-6E97-7D69-E1791493553B}"/>
-              </a:ext>
-            </a:extLst>
-          </p:cNvPr>
-          <p:cNvPicPr>
-            <a:picLocks noChangeAspect="1"/>
-          </p:cNvPicPr>
-          <p:nvPr/>
-        </p:nvPicPr>
-        <p:blipFill>
-          <a:blip r:embed="rId3"/>
-          <a:srcRect t="5115"/>
-          <a:stretch/>
-        </p:blipFill>
-        <p:spPr>
-          <a:xfrm>
-            <a:off x="3953595" y="1424940"/>
-            <a:ext cx="4878705" cy="3086099"/>
-          </a:xfrm>
-          <a:prstGeom prst="rect">
-            <a:avLst/>
-          </a:prstGeom>
-        </p:spPr>
-      </p:pic>
-      <p:cxnSp>
-        <p:nvCxnSpPr>
-          <p:cNvPr id="7" name="Straight Connector 6">
-            <a:extLst>
-              <a:ext uri="{FF2B5EF4-FFF2-40B4-BE49-F238E27FC236}">
-                <a16:creationId xmlns:a16="http://schemas.microsoft.com/office/drawing/2014/main" id="{80958559-3D62-1462-D80F-B7102E96676A}"/>
-              </a:ext>
-            </a:extLst>
-          </p:cNvPr>
-          <p:cNvCxnSpPr>
-            <a:cxnSpLocks/>
-          </p:cNvCxnSpPr>
-          <p:nvPr/>
-        </p:nvCxnSpPr>
-        <p:spPr>
-          <a:xfrm>
-            <a:off x="3923115" y="1066800"/>
-            <a:ext cx="0" cy="3886200"/>
-          </a:xfrm>
-          <a:prstGeom prst="line">
-            <a:avLst/>
-          </a:prstGeom>
-          <a:ln w="9525"/>
-        </p:spPr>
-        <p:style>
-          <a:lnRef idx="1">
-            <a:schemeClr val="dk1"/>
-          </a:lnRef>
-          <a:fillRef idx="0">
-            <a:schemeClr val="dk1"/>
-          </a:fillRef>
-          <a:effectRef idx="0">
-            <a:schemeClr val="dk1"/>
-          </a:effectRef>
-          <a:fontRef idx="minor">
-            <a:schemeClr val="tx1"/>
-          </a:fontRef>
-        </p:style>
-      </p:cxnSp>
-      <p:sp>
-        <p:nvSpPr>
-          <p:cNvPr id="9" name="TextBox 8">
-            <a:extLst>
-              <a:ext uri="{FF2B5EF4-FFF2-40B4-BE49-F238E27FC236}">
-                <a16:creationId xmlns:a16="http://schemas.microsoft.com/office/drawing/2014/main" id="{2D254120-E3D2-87D6-DA03-6E4ECE6C3E03}"/>
-              </a:ext>
-            </a:extLst>
-          </p:cNvPr>
-          <p:cNvSpPr txBox="1"/>
-          <p:nvPr/>
-        </p:nvSpPr>
-        <p:spPr>
-          <a:xfrm>
-            <a:off x="134113" y="829170"/>
-            <a:ext cx="4437887" cy="276999"/>
-          </a:xfrm>
-          <a:prstGeom prst="rect">
-            <a:avLst/>
-          </a:prstGeom>
-          <a:noFill/>
-        </p:spPr>
-        <p:txBody>
-          <a:bodyPr wrap="square" rtlCol="0">
-            <a:spAutoFit/>
-          </a:bodyPr>
-          <a:lstStyle/>
-          <a:p>
-            <a:r>
-              <a:rPr lang="it-IT" sz="1200" dirty="0">
-                <a:latin typeface="Open Sans" panose="020B0606030504020204" pitchFamily="34" charset="0"/>
-                <a:ea typeface="Open Sans" panose="020B0606030504020204" pitchFamily="34" charset="0"/>
-                <a:cs typeface="Open Sans" panose="020B0606030504020204" pitchFamily="34" charset="0"/>
-              </a:rPr>
-              <a:t>SHAP summary plot – 20 most important features</a:t>
-            </a:r>
-          </a:p>
-        </p:txBody>
-      </p:sp>
-      <p:pic>
-        <p:nvPicPr>
-          <p:cNvPr id="13" name="Picture 12" descr="A screen shot of a graph&#10;&#10;AI-generated content may be incorrect.">
-            <a:extLst>
-              <a:ext uri="{FF2B5EF4-FFF2-40B4-BE49-F238E27FC236}">
-                <a16:creationId xmlns:a16="http://schemas.microsoft.com/office/drawing/2014/main" id="{62661D18-C171-0F0D-9E0B-C8C8EF5D4CC1}"/>
-              </a:ext>
-            </a:extLst>
-          </p:cNvPr>
-          <p:cNvPicPr>
-            <a:picLocks noChangeAspect="1"/>
-          </p:cNvPicPr>
-          <p:nvPr/>
-        </p:nvPicPr>
-        <p:blipFill>
-          <a:blip r:embed="rId4"/>
-          <a:stretch>
-            <a:fillRect/>
-          </a:stretch>
-        </p:blipFill>
-        <p:spPr>
-          <a:xfrm>
-            <a:off x="529751" y="1059801"/>
-            <a:ext cx="3263703" cy="3938230"/>
-          </a:xfrm>
-          <a:prstGeom prst="rect">
-            <a:avLst/>
-          </a:prstGeom>
-        </p:spPr>
-      </p:pic>
-      <p:sp>
-        <p:nvSpPr>
-          <p:cNvPr id="14" name="TextBox 13">
-            <a:extLst>
-              <a:ext uri="{FF2B5EF4-FFF2-40B4-BE49-F238E27FC236}">
-                <a16:creationId xmlns:a16="http://schemas.microsoft.com/office/drawing/2014/main" id="{A818A1B8-AE86-08C1-7083-CB94F74217F5}"/>
-              </a:ext>
-            </a:extLst>
-          </p:cNvPr>
-          <p:cNvSpPr txBox="1"/>
-          <p:nvPr/>
-        </p:nvSpPr>
-        <p:spPr>
-          <a:xfrm>
-            <a:off x="4825108" y="1090718"/>
-            <a:ext cx="4437887" cy="276999"/>
-          </a:xfrm>
-          <a:prstGeom prst="rect">
-            <a:avLst/>
-          </a:prstGeom>
-          <a:noFill/>
-        </p:spPr>
-        <p:txBody>
-          <a:bodyPr wrap="square" rtlCol="0">
-            <a:spAutoFit/>
-          </a:bodyPr>
-          <a:lstStyle/>
-          <a:p>
-            <a:r>
-              <a:rPr lang="it-IT" sz="1200" dirty="0">
-                <a:latin typeface="Open Sans" panose="020B0606030504020204" pitchFamily="34" charset="0"/>
-                <a:ea typeface="Open Sans" panose="020B0606030504020204" pitchFamily="34" charset="0"/>
-                <a:cs typeface="Open Sans" panose="020B0606030504020204" pitchFamily="34" charset="0"/>
-              </a:rPr>
-              <a:t>Why did the model classify article 1 like this?</a:t>
-            </a:r>
-          </a:p>
-        </p:txBody>
-      </p:sp>
     </p:spTree>
     <p:extLst>
       <p:ext uri="{BB962C8B-B14F-4D97-AF65-F5344CB8AC3E}">
-        <p14:creationId xmlns:p14="http://schemas.microsoft.com/office/powerpoint/2010/main" val="4080359590"/>
+        <p14:creationId xmlns:p14="http://schemas.microsoft.com/office/powerpoint/2010/main" val="779754174"/>
       </p:ext>
     </p:extLst>
   </p:cSld>
@@ -16837,6 +17269,343 @@
                 <a:cs typeface="Roboto Serif"/>
                 <a:sym typeface="Roboto Serif"/>
               </a:rPr>
+              <a:t>Model explainability</a:t>
+            </a:r>
+            <a:endParaRPr sz="3720" b="1" dirty="0">
+              <a:latin typeface="Roboto Serif"/>
+              <a:ea typeface="Roboto Serif"/>
+              <a:cs typeface="Roboto Serif"/>
+              <a:sym typeface="Roboto Serif"/>
+            </a:endParaRPr>
+          </a:p>
+        </p:txBody>
+      </p:sp>
+      <p:sp>
+        <p:nvSpPr>
+          <p:cNvPr id="68" name="Google Shape;68;p14"/>
+          <p:cNvSpPr txBox="1">
+            <a:spLocks noGrp="1"/>
+          </p:cNvSpPr>
+          <p:nvPr>
+            <p:ph type="sldNum" idx="12"/>
+          </p:nvPr>
+        </p:nvSpPr>
+        <p:spPr>
+          <a:xfrm>
+            <a:off x="8472458" y="4663217"/>
+            <a:ext cx="548700" cy="393600"/>
+          </a:xfrm>
+          <a:prstGeom prst="rect">
+            <a:avLst/>
+          </a:prstGeom>
+        </p:spPr>
+        <p:txBody>
+          <a:bodyPr spcFirstLastPara="1" wrap="square" lIns="91425" tIns="91425" rIns="91425" bIns="91425" anchor="ctr" anchorCtr="0">
+            <a:normAutofit/>
+          </a:bodyPr>
+          <a:lstStyle/>
+          <a:p>
+            <a:pPr marL="0" lvl="0" indent="0" algn="r" rtl="0">
+              <a:spcBef>
+                <a:spcPts val="0"/>
+              </a:spcBef>
+              <a:spcAft>
+                <a:spcPts val="0"/>
+              </a:spcAft>
+              <a:buNone/>
+            </a:pPr>
+            <a:r>
+              <a:rPr lang="it" dirty="0">
+                <a:latin typeface="Times New Roman"/>
+                <a:ea typeface="Times New Roman"/>
+                <a:cs typeface="Times New Roman"/>
+                <a:sym typeface="Times New Roman"/>
+              </a:rPr>
+              <a:t>25/27</a:t>
+            </a:r>
+            <a:endParaRPr dirty="0">
+              <a:latin typeface="Times New Roman"/>
+              <a:ea typeface="Times New Roman"/>
+              <a:cs typeface="Times New Roman"/>
+              <a:sym typeface="Times New Roman"/>
+            </a:endParaRPr>
+          </a:p>
+        </p:txBody>
+      </p:sp>
+      <p:cxnSp>
+        <p:nvCxnSpPr>
+          <p:cNvPr id="69" name="Google Shape;69;p14"/>
+          <p:cNvCxnSpPr/>
+          <p:nvPr/>
+        </p:nvCxnSpPr>
+        <p:spPr>
+          <a:xfrm>
+            <a:off x="276600" y="789125"/>
+            <a:ext cx="4295400" cy="0"/>
+          </a:xfrm>
+          <a:prstGeom prst="straightConnector1">
+            <a:avLst/>
+          </a:prstGeom>
+          <a:noFill/>
+          <a:ln w="9525" cap="flat" cmpd="sng">
+            <a:solidFill>
+              <a:schemeClr val="dk2"/>
+            </a:solidFill>
+            <a:prstDash val="solid"/>
+            <a:round/>
+            <a:headEnd type="none" w="med" len="med"/>
+            <a:tailEnd type="none" w="med" len="med"/>
+          </a:ln>
+        </p:spPr>
+      </p:cxnSp>
+      <p:pic>
+        <p:nvPicPr>
+          <p:cNvPr id="5" name="Picture 4" descr="A graph with numbers and text&#10;&#10;AI-generated content may be incorrect.">
+            <a:extLst>
+              <a:ext uri="{FF2B5EF4-FFF2-40B4-BE49-F238E27FC236}">
+                <a16:creationId xmlns:a16="http://schemas.microsoft.com/office/drawing/2014/main" id="{AD0649EA-B411-6E97-7D69-E1791493553B}"/>
+              </a:ext>
+            </a:extLst>
+          </p:cNvPr>
+          <p:cNvPicPr>
+            <a:picLocks noChangeAspect="1"/>
+          </p:cNvPicPr>
+          <p:nvPr/>
+        </p:nvPicPr>
+        <p:blipFill>
+          <a:blip r:embed="rId3"/>
+          <a:srcRect t="5115"/>
+          <a:stretch/>
+        </p:blipFill>
+        <p:spPr>
+          <a:xfrm>
+            <a:off x="3953595" y="1424940"/>
+            <a:ext cx="4878705" cy="3086099"/>
+          </a:xfrm>
+          <a:prstGeom prst="rect">
+            <a:avLst/>
+          </a:prstGeom>
+        </p:spPr>
+      </p:pic>
+      <p:cxnSp>
+        <p:nvCxnSpPr>
+          <p:cNvPr id="7" name="Straight Connector 6">
+            <a:extLst>
+              <a:ext uri="{FF2B5EF4-FFF2-40B4-BE49-F238E27FC236}">
+                <a16:creationId xmlns:a16="http://schemas.microsoft.com/office/drawing/2014/main" id="{80958559-3D62-1462-D80F-B7102E96676A}"/>
+              </a:ext>
+            </a:extLst>
+          </p:cNvPr>
+          <p:cNvCxnSpPr>
+            <a:cxnSpLocks/>
+          </p:cNvCxnSpPr>
+          <p:nvPr/>
+        </p:nvCxnSpPr>
+        <p:spPr>
+          <a:xfrm>
+            <a:off x="3923115" y="1066800"/>
+            <a:ext cx="0" cy="3886200"/>
+          </a:xfrm>
+          <a:prstGeom prst="line">
+            <a:avLst/>
+          </a:prstGeom>
+          <a:ln w="9525"/>
+        </p:spPr>
+        <p:style>
+          <a:lnRef idx="1">
+            <a:schemeClr val="dk1"/>
+          </a:lnRef>
+          <a:fillRef idx="0">
+            <a:schemeClr val="dk1"/>
+          </a:fillRef>
+          <a:effectRef idx="0">
+            <a:schemeClr val="dk1"/>
+          </a:effectRef>
+          <a:fontRef idx="minor">
+            <a:schemeClr val="tx1"/>
+          </a:fontRef>
+        </p:style>
+      </p:cxnSp>
+      <p:sp>
+        <p:nvSpPr>
+          <p:cNvPr id="9" name="TextBox 8">
+            <a:extLst>
+              <a:ext uri="{FF2B5EF4-FFF2-40B4-BE49-F238E27FC236}">
+                <a16:creationId xmlns:a16="http://schemas.microsoft.com/office/drawing/2014/main" id="{2D254120-E3D2-87D6-DA03-6E4ECE6C3E03}"/>
+              </a:ext>
+            </a:extLst>
+          </p:cNvPr>
+          <p:cNvSpPr txBox="1"/>
+          <p:nvPr/>
+        </p:nvSpPr>
+        <p:spPr>
+          <a:xfrm>
+            <a:off x="134113" y="829170"/>
+            <a:ext cx="4437887" cy="276999"/>
+          </a:xfrm>
+          <a:prstGeom prst="rect">
+            <a:avLst/>
+          </a:prstGeom>
+          <a:noFill/>
+        </p:spPr>
+        <p:txBody>
+          <a:bodyPr wrap="square" rtlCol="0">
+            <a:spAutoFit/>
+          </a:bodyPr>
+          <a:lstStyle/>
+          <a:p>
+            <a:r>
+              <a:rPr lang="it-IT" sz="1200" dirty="0">
+                <a:latin typeface="Open Sans" panose="020B0606030504020204" pitchFamily="34" charset="0"/>
+                <a:ea typeface="Open Sans" panose="020B0606030504020204" pitchFamily="34" charset="0"/>
+                <a:cs typeface="Open Sans" panose="020B0606030504020204" pitchFamily="34" charset="0"/>
+              </a:rPr>
+              <a:t>SHAP summary plot – 20 most important features</a:t>
+            </a:r>
+          </a:p>
+        </p:txBody>
+      </p:sp>
+      <p:pic>
+        <p:nvPicPr>
+          <p:cNvPr id="13" name="Picture 12" descr="A screen shot of a graph&#10;&#10;AI-generated content may be incorrect.">
+            <a:extLst>
+              <a:ext uri="{FF2B5EF4-FFF2-40B4-BE49-F238E27FC236}">
+                <a16:creationId xmlns:a16="http://schemas.microsoft.com/office/drawing/2014/main" id="{62661D18-C171-0F0D-9E0B-C8C8EF5D4CC1}"/>
+              </a:ext>
+            </a:extLst>
+          </p:cNvPr>
+          <p:cNvPicPr>
+            <a:picLocks noChangeAspect="1"/>
+          </p:cNvPicPr>
+          <p:nvPr/>
+        </p:nvPicPr>
+        <p:blipFill>
+          <a:blip r:embed="rId4"/>
+          <a:stretch>
+            <a:fillRect/>
+          </a:stretch>
+        </p:blipFill>
+        <p:spPr>
+          <a:xfrm>
+            <a:off x="529751" y="1059801"/>
+            <a:ext cx="3263703" cy="3938230"/>
+          </a:xfrm>
+          <a:prstGeom prst="rect">
+            <a:avLst/>
+          </a:prstGeom>
+        </p:spPr>
+      </p:pic>
+      <p:sp>
+        <p:nvSpPr>
+          <p:cNvPr id="14" name="TextBox 13">
+            <a:extLst>
+              <a:ext uri="{FF2B5EF4-FFF2-40B4-BE49-F238E27FC236}">
+                <a16:creationId xmlns:a16="http://schemas.microsoft.com/office/drawing/2014/main" id="{A818A1B8-AE86-08C1-7083-CB94F74217F5}"/>
+              </a:ext>
+            </a:extLst>
+          </p:cNvPr>
+          <p:cNvSpPr txBox="1"/>
+          <p:nvPr/>
+        </p:nvSpPr>
+        <p:spPr>
+          <a:xfrm>
+            <a:off x="4825108" y="1090718"/>
+            <a:ext cx="4437887" cy="276999"/>
+          </a:xfrm>
+          <a:prstGeom prst="rect">
+            <a:avLst/>
+          </a:prstGeom>
+          <a:noFill/>
+        </p:spPr>
+        <p:txBody>
+          <a:bodyPr wrap="square" rtlCol="0">
+            <a:spAutoFit/>
+          </a:bodyPr>
+          <a:lstStyle/>
+          <a:p>
+            <a:r>
+              <a:rPr lang="it-IT" sz="1200" dirty="0">
+                <a:latin typeface="Open Sans" panose="020B0606030504020204" pitchFamily="34" charset="0"/>
+                <a:ea typeface="Open Sans" panose="020B0606030504020204" pitchFamily="34" charset="0"/>
+                <a:cs typeface="Open Sans" panose="020B0606030504020204" pitchFamily="34" charset="0"/>
+              </a:rPr>
+              <a:t>Why did the model classify article 1 like this?</a:t>
+            </a:r>
+          </a:p>
+        </p:txBody>
+      </p:sp>
+    </p:spTree>
+    <p:extLst>
+      <p:ext uri="{BB962C8B-B14F-4D97-AF65-F5344CB8AC3E}">
+        <p14:creationId xmlns:p14="http://schemas.microsoft.com/office/powerpoint/2010/main" val="4080359590"/>
+      </p:ext>
+    </p:extLst>
+  </p:cSld>
+  <p:clrMapOvr>
+    <a:masterClrMapping/>
+  </p:clrMapOvr>
+</p:sld>
+</file>
+
+<file path=ppt/slides/slide28.xml><?xml version="1.0" encoding="utf-8"?>
+<p:sld xmlns:a="http://schemas.openxmlformats.org/drawingml/2006/main" xmlns:r="http://schemas.openxmlformats.org/officeDocument/2006/relationships" xmlns:p="http://schemas.openxmlformats.org/presentationml/2006/main">
+  <p:cSld>
+    <p:spTree>
+      <p:nvGrpSpPr>
+        <p:cNvPr id="1" name="Shape 65"/>
+        <p:cNvGrpSpPr/>
+        <p:nvPr/>
+      </p:nvGrpSpPr>
+      <p:grpSpPr>
+        <a:xfrm>
+          <a:off x="0" y="0"/>
+          <a:ext cx="0" cy="0"/>
+          <a:chOff x="0" y="0"/>
+          <a:chExt cx="0" cy="0"/>
+        </a:xfrm>
+      </p:grpSpPr>
+      <p:sp>
+        <p:nvSpPr>
+          <p:cNvPr id="66" name="Google Shape;66;p14"/>
+          <p:cNvSpPr txBox="1">
+            <a:spLocks noGrp="1"/>
+          </p:cNvSpPr>
+          <p:nvPr>
+            <p:ph type="title"/>
+          </p:nvPr>
+        </p:nvSpPr>
+        <p:spPr>
+          <a:xfrm>
+            <a:off x="311700" y="64025"/>
+            <a:ext cx="8520600" cy="572700"/>
+          </a:xfrm>
+          <a:prstGeom prst="rect">
+            <a:avLst/>
+          </a:prstGeom>
+        </p:spPr>
+        <p:txBody>
+          <a:bodyPr spcFirstLastPara="1" wrap="square" lIns="91425" tIns="91425" rIns="91425" bIns="91425" anchor="t" anchorCtr="0">
+            <a:noAutofit/>
+          </a:bodyPr>
+          <a:lstStyle/>
+          <a:p>
+            <a:pPr marL="0" lvl="0" indent="0" algn="l" rtl="0">
+              <a:spcBef>
+                <a:spcPts val="0"/>
+              </a:spcBef>
+              <a:spcAft>
+                <a:spcPts val="0"/>
+              </a:spcAft>
+              <a:buSzPts val="990"/>
+              <a:buNone/>
+            </a:pPr>
+            <a:r>
+              <a:rPr lang="it-IT" sz="3720" b="1" dirty="0">
+                <a:latin typeface="Roboto Serif"/>
+                <a:ea typeface="Roboto Serif"/>
+                <a:cs typeface="Roboto Serif"/>
+                <a:sym typeface="Roboto Serif"/>
+              </a:rPr>
               <a:t>Our App</a:t>
             </a:r>
             <a:endParaRPr sz="3720" b="1" dirty="0">
@@ -17115,7 +17884,7 @@
 </p:sld>
 </file>
 
-<file path=ppt/slides/slide28.xml><?xml version="1.0" encoding="utf-8"?>
+<file path=ppt/slides/slide29.xml><?xml version="1.0" encoding="utf-8"?>
 <p:sld xmlns:a="http://schemas.openxmlformats.org/drawingml/2006/main" xmlns:r="http://schemas.openxmlformats.org/officeDocument/2006/relationships" xmlns:p="http://schemas.openxmlformats.org/presentationml/2006/main">
   <p:cSld>
     <p:spTree>

</xml_diff>